<commit_message>
deck: add category-stability card and sync figures with the product
Slide 8 now reports that high-risk customer count stays 3 -> 3 after the
weight bump, because a customer's category is the maximum over its services
and the stronger weight lifts medium clients' scores without crossing the
65 threshold. values.py derives high_before/high_after from the engine.

Co-authored-by: openhands <openhands@all-hands.dev>
</commit_message>
<xml_diff>
--- a/aeza_hackathon_osen_2026.pptx
+++ b/aeza_hackathon_osen_2026.pptx
@@ -19165,14 +19165,60 @@
       </p:sp>
       <p:sp>
         <p:nvSpPr>
-          <p:cNvPr id="30" name="TextBox 29"/>
+          <p:cNvPr id="30" name="Rectangle 29"/>
+          <p:cNvSpPr/>
+          <p:nvPr/>
+        </p:nvSpPr>
+        <p:spPr>
+          <a:xfrm>
+            <a:off x="7999780" y="4745736"/>
+            <a:ext cx="3533546" cy="640080"/>
+          </a:xfrm>
+          <a:prstGeom prst="rect">
+            <a:avLst/>
+          </a:prstGeom>
+          <a:solidFill>
+            <a:srgbClr val="FFFFFF"/>
+          </a:solidFill>
+          <a:ln w="11430">
+            <a:solidFill>
+              <a:srgbClr val="E1E1E1"/>
+            </a:solidFill>
+          </a:ln>
+          <a:effectLst/>
+        </p:spPr>
+        <p:style>
+          <a:lnRef idx="1">
+            <a:schemeClr val="accent1"/>
+          </a:lnRef>
+          <a:fillRef idx="3">
+            <a:schemeClr val="accent1"/>
+          </a:fillRef>
+          <a:effectRef idx="2">
+            <a:schemeClr val="accent1"/>
+          </a:effectRef>
+          <a:fontRef idx="minor">
+            <a:schemeClr val="lt1"/>
+          </a:fontRef>
+        </p:style>
+        <p:txBody>
+          <a:bodyPr rtlCol="0" anchor="ctr"/>
+          <a:lstStyle/>
+          <a:p>
+            <a:pPr algn="ctr"/>
+          </a:p>
+        </p:txBody>
+      </p:sp>
+      <p:sp>
+        <p:nvSpPr>
+          <p:cNvPr id="31" name="TextBox 30"/>
           <p:cNvSpPr txBox="1"/>
           <p:nvPr/>
         </p:nvSpPr>
         <p:spPr>
           <a:xfrm>
-            <a:off x="658368" y="5641848"/>
-            <a:ext cx="10874959" cy="364998"/>
+            <a:off x="8146084" y="4837176"/>
+            <a:ext cx="3240938" cy="131635"/>
           </a:xfrm>
           <a:prstGeom prst="rect">
             <a:avLst/>
@@ -19187,27 +19233,119 @@
           <a:p>
             <a:pPr algn="l">
               <a:lnSpc>
-                <a:spcPct val="130000"/>
-              </a:lnSpc>
-              <a:spcBef>
-                <a:spcPts val="0"/>
-              </a:spcBef>
-              <a:spcAft>
-                <a:spcPts val="0"/>
-              </a:spcAft>
-            </a:pPr>
-            <a:r>
-              <a:rPr sz="1050" b="0" i="0">
+                <a:spcPct val="105000"/>
+              </a:lnSpc>
+              <a:spcBef>
+                <a:spcPts val="0"/>
+              </a:spcBef>
+              <a:spcAft>
+                <a:spcPts val="0"/>
+              </a:spcAft>
+            </a:pPr>
+            <a:r>
+              <a:rPr sz="850" b="1" i="0">
                 <a:solidFill>
                   <a:srgbClr val="666666"/>
+                </a:solidFill>
+                <a:latin typeface="Manrope SemiBold"/>
+                <a:cs typeface="Manrope SemiBold"/>
+                <a:ea typeface="Manrope SemiBold"/>
+              </a:rPr>
+              <a:t>Клиентов высокого риска</a:t>
+            </a:r>
+          </a:p>
+        </p:txBody>
+      </p:sp>
+      <p:sp>
+        <p:nvSpPr>
+          <p:cNvPr id="32" name="TextBox 31"/>
+          <p:cNvSpPr txBox="1"/>
+          <p:nvPr/>
+        </p:nvSpPr>
+        <p:spPr>
+          <a:xfrm>
+            <a:off x="8146084" y="5020056"/>
+            <a:ext cx="3240938" cy="310896"/>
+          </a:xfrm>
+          <a:prstGeom prst="rect">
+            <a:avLst/>
+          </a:prstGeom>
+          <a:noFill/>
+        </p:spPr>
+        <p:txBody>
+          <a:bodyPr wrap="square" anchor="t" lIns="0" rIns="0" tIns="0" bIns="0">
+            <a:spAutoFit/>
+          </a:bodyPr>
+          <a:lstStyle/>
+          <a:p>
+            <a:pPr algn="l">
+              <a:lnSpc>
+                <a:spcPct val="116000"/>
+              </a:lnSpc>
+              <a:spcBef>
+                <a:spcPts val="0"/>
+              </a:spcBef>
+              <a:spcAft>
+                <a:spcPts val="0"/>
+              </a:spcAft>
+            </a:pPr>
+            <a:r>
+              <a:rPr sz="1500" b="0">
+                <a:solidFill>
+                  <a:srgbClr val="666666"/>
+                </a:solidFill>
+                <a:latin typeface="Manrope Medium"/>
+                <a:cs typeface="Manrope Medium"/>
+                <a:ea typeface="Manrope Medium"/>
+              </a:rPr>
+              <a:t>3</a:t>
+            </a:r>
+            <a:r>
+              <a:rPr sz="1500" b="0">
+                <a:solidFill>
+                  <a:srgbClr val="C9C9C9"/>
+                </a:solidFill>
+                <a:latin typeface="Manrope Medium"/>
+                <a:cs typeface="Manrope Medium"/>
+                <a:ea typeface="Manrope Medium"/>
+              </a:rPr>
+              <a:t>   →   </a:t>
+            </a:r>
+            <a:r>
+              <a:rPr sz="1500" b="1">
+                <a:solidFill>
+                  <a:srgbClr val="B84A00"/>
                 </a:solidFill>
                 <a:latin typeface="Manrope"/>
                 <a:cs typeface="Manrope"/>
                 <a:ea typeface="Manrope"/>
               </a:rPr>
-              <a:t>Расчёт: сумма весов выросла с 13.0 до 19.0, вклад фактора — с 3.0 до 9.0, поэтому балл service-0030 стал 81,8, а услуг высокого риска — 7 вместо 4. Настройка сохраняется на</a:t>
-            </a:r>
-          </a:p>
+              <a:t>3</a:t>
+            </a:r>
+          </a:p>
+        </p:txBody>
+      </p:sp>
+      <p:sp>
+        <p:nvSpPr>
+          <p:cNvPr id="33" name="TextBox 32"/>
+          <p:cNvSpPr txBox="1"/>
+          <p:nvPr/>
+        </p:nvSpPr>
+        <p:spPr>
+          <a:xfrm>
+            <a:off x="658368" y="5641848"/>
+            <a:ext cx="10874959" cy="538353"/>
+          </a:xfrm>
+          <a:prstGeom prst="rect">
+            <a:avLst/>
+          </a:prstGeom>
+          <a:noFill/>
+        </p:spPr>
+        <p:txBody>
+          <a:bodyPr wrap="square" anchor="t" lIns="0" rIns="0" tIns="0" bIns="0">
+            <a:spAutoFit/>
+          </a:bodyPr>
+          <a:lstStyle/>
           <a:p>
             <a:pPr algn="l">
               <a:lnSpc>
@@ -19229,7 +19367,55 @@
                 <a:cs typeface="Manrope"/>
                 <a:ea typeface="Manrope"/>
               </a:rPr>
-              <a:t>сервере, сводка обновляется сразу, без перезагрузки страницы; кнопка «Значения по умолчанию» возвращает исходные 3,0 и прежние числа.</a:t>
+              <a:t>Расчёт: сумма весов выросла с 13.0 до 19.0, вклад фактора — с 3.0 до 9.0, поэтому балл service-0030 стал 81,8, а услуг высокого риска — 7 вместо 4. Клиентов высокого риска</a:t>
+            </a:r>
+          </a:p>
+          <a:p>
+            <a:pPr algn="l">
+              <a:lnSpc>
+                <a:spcPct val="130000"/>
+              </a:lnSpc>
+              <a:spcBef>
+                <a:spcPts val="0"/>
+              </a:spcBef>
+              <a:spcAft>
+                <a:spcPts val="0"/>
+              </a:spcAft>
+            </a:pPr>
+            <a:r>
+              <a:rPr sz="1050" b="0" i="0">
+                <a:solidFill>
+                  <a:srgbClr val="666666"/>
+                </a:solidFill>
+                <a:latin typeface="Manrope"/>
+                <a:cs typeface="Manrope"/>
+                <a:ea typeface="Manrope"/>
+              </a:rPr>
+              <a:t>осталось 3: категория клиента — это максимум по его услугам, и усиленный вес поднял баллы средних клиентов, но не выше порога 65. Настройка сохраняется на сервере, сводка</a:t>
+            </a:r>
+          </a:p>
+          <a:p>
+            <a:pPr algn="l">
+              <a:lnSpc>
+                <a:spcPct val="130000"/>
+              </a:lnSpc>
+              <a:spcBef>
+                <a:spcPts val="0"/>
+              </a:spcBef>
+              <a:spcAft>
+                <a:spcPts val="0"/>
+              </a:spcAft>
+            </a:pPr>
+            <a:r>
+              <a:rPr sz="1050" b="0" i="0">
+                <a:solidFill>
+                  <a:srgbClr val="666666"/>
+                </a:solidFill>
+                <a:latin typeface="Manrope"/>
+                <a:cs typeface="Manrope"/>
+                <a:ea typeface="Manrope"/>
+              </a:rPr>
+              <a:t>обновляется сразу, без перезагрузки страницы; кнопка «Значения по умолчанию» возвращает исходные 3,0 и прежние числа.</a:t>
             </a:r>
           </a:p>
         </p:txBody>

</xml_diff>